<commit_message>
Add new & Update ppts
</commit_message>
<xml_diff>
--- a/Hi-Ne-Ni.pptx
+++ b/Hi-Ne-Ni.pptx
@@ -169,10 +169,9 @@
           <a:lstStyle/>
           <a:p>
             <a:r>
-              <a:rPr lang="zh-TW" altLang="en-US" smtClean="0"/>
+              <a:rPr lang="zh-TW" altLang="en-US"/>
               <a:t>按一下以編輯母片標題樣式</a:t>
             </a:r>
-            <a:endParaRPr lang="zh-TW" altLang="en-US"/>
           </a:p>
         </p:txBody>
       </p:sp>
@@ -288,10 +287,9 @@
           </a:lstStyle>
           <a:p>
             <a:r>
-              <a:rPr lang="zh-TW" altLang="en-US" smtClean="0"/>
+              <a:rPr lang="zh-TW" altLang="en-US"/>
               <a:t>按一下以編輯母片副標題樣式</a:t>
             </a:r>
-            <a:endParaRPr lang="zh-TW" altLang="en-US"/>
           </a:p>
         </p:txBody>
       </p:sp>
@@ -313,7 +311,7 @@
             <a:fld id="{8ABE99C2-CC00-45DE-B879-1B21F9649AC3}" type="datetimeFigureOut">
               <a:rPr lang="en-US" smtClean="0"/>
               <a:pPr/>
-              <a:t>2/11/2023</a:t>
+              <a:t>4/12/2025</a:t>
             </a:fld>
             <a:endParaRPr lang="en-US"/>
           </a:p>
@@ -403,10 +401,9 @@
           <a:lstStyle/>
           <a:p>
             <a:r>
-              <a:rPr lang="zh-TW" altLang="en-US" smtClean="0"/>
+              <a:rPr lang="zh-TW" altLang="en-US"/>
               <a:t>按一下以編輯母片標題樣式</a:t>
             </a:r>
-            <a:endParaRPr lang="zh-TW" altLang="en-US"/>
           </a:p>
         </p:txBody>
       </p:sp>
@@ -427,38 +424,37 @@
           <a:p>
             <a:pPr lvl="0"/>
             <a:r>
-              <a:rPr lang="zh-TW" altLang="en-US" smtClean="0"/>
+              <a:rPr lang="zh-TW" altLang="en-US"/>
               <a:t>按一下以編輯母片文字樣式</a:t>
             </a:r>
           </a:p>
           <a:p>
             <a:pPr lvl="1"/>
             <a:r>
-              <a:rPr lang="zh-TW" altLang="en-US" smtClean="0"/>
+              <a:rPr lang="zh-TW" altLang="en-US"/>
               <a:t>第二層</a:t>
             </a:r>
           </a:p>
           <a:p>
             <a:pPr lvl="2"/>
             <a:r>
-              <a:rPr lang="zh-TW" altLang="en-US" smtClean="0"/>
+              <a:rPr lang="zh-TW" altLang="en-US"/>
               <a:t>第三層</a:t>
             </a:r>
           </a:p>
           <a:p>
             <a:pPr lvl="3"/>
             <a:r>
-              <a:rPr lang="zh-TW" altLang="en-US" smtClean="0"/>
+              <a:rPr lang="zh-TW" altLang="en-US"/>
               <a:t>第四層</a:t>
             </a:r>
           </a:p>
           <a:p>
             <a:pPr lvl="4"/>
             <a:r>
-              <a:rPr lang="zh-TW" altLang="en-US" smtClean="0"/>
+              <a:rPr lang="zh-TW" altLang="en-US"/>
               <a:t>第五層</a:t>
             </a:r>
-            <a:endParaRPr lang="zh-TW" altLang="en-US"/>
           </a:p>
         </p:txBody>
       </p:sp>
@@ -480,7 +476,7 @@
             <a:fld id="{8ABE99C2-CC00-45DE-B879-1B21F9649AC3}" type="datetimeFigureOut">
               <a:rPr lang="en-US" smtClean="0"/>
               <a:pPr/>
-              <a:t>2/11/2023</a:t>
+              <a:t>4/12/2025</a:t>
             </a:fld>
             <a:endParaRPr lang="en-US"/>
           </a:p>
@@ -575,10 +571,9 @@
           <a:lstStyle/>
           <a:p>
             <a:r>
-              <a:rPr lang="zh-TW" altLang="en-US" smtClean="0"/>
+              <a:rPr lang="zh-TW" altLang="en-US"/>
               <a:t>按一下以編輯母片標題樣式</a:t>
             </a:r>
-            <a:endParaRPr lang="zh-TW" altLang="en-US"/>
           </a:p>
         </p:txBody>
       </p:sp>
@@ -604,38 +599,37 @@
           <a:p>
             <a:pPr lvl="0"/>
             <a:r>
-              <a:rPr lang="zh-TW" altLang="en-US" smtClean="0"/>
+              <a:rPr lang="zh-TW" altLang="en-US"/>
               <a:t>按一下以編輯母片文字樣式</a:t>
             </a:r>
           </a:p>
           <a:p>
             <a:pPr lvl="1"/>
             <a:r>
-              <a:rPr lang="zh-TW" altLang="en-US" smtClean="0"/>
+              <a:rPr lang="zh-TW" altLang="en-US"/>
               <a:t>第二層</a:t>
             </a:r>
           </a:p>
           <a:p>
             <a:pPr lvl="2"/>
             <a:r>
-              <a:rPr lang="zh-TW" altLang="en-US" smtClean="0"/>
+              <a:rPr lang="zh-TW" altLang="en-US"/>
               <a:t>第三層</a:t>
             </a:r>
           </a:p>
           <a:p>
             <a:pPr lvl="3"/>
             <a:r>
-              <a:rPr lang="zh-TW" altLang="en-US" smtClean="0"/>
+              <a:rPr lang="zh-TW" altLang="en-US"/>
               <a:t>第四層</a:t>
             </a:r>
           </a:p>
           <a:p>
             <a:pPr lvl="4"/>
             <a:r>
-              <a:rPr lang="zh-TW" altLang="en-US" smtClean="0"/>
+              <a:rPr lang="zh-TW" altLang="en-US"/>
               <a:t>第五層</a:t>
             </a:r>
-            <a:endParaRPr lang="zh-TW" altLang="en-US"/>
           </a:p>
         </p:txBody>
       </p:sp>
@@ -657,7 +651,7 @@
             <a:fld id="{8ABE99C2-CC00-45DE-B879-1B21F9649AC3}" type="datetimeFigureOut">
               <a:rPr lang="en-US" smtClean="0"/>
               <a:pPr/>
-              <a:t>2/11/2023</a:t>
+              <a:t>4/12/2025</a:t>
             </a:fld>
             <a:endParaRPr lang="en-US"/>
           </a:p>
@@ -747,10 +741,9 @@
           <a:lstStyle/>
           <a:p>
             <a:r>
-              <a:rPr lang="zh-TW" altLang="en-US" smtClean="0"/>
+              <a:rPr lang="zh-TW" altLang="en-US"/>
               <a:t>按一下以編輯母片標題樣式</a:t>
             </a:r>
-            <a:endParaRPr lang="zh-TW" altLang="en-US"/>
           </a:p>
         </p:txBody>
       </p:sp>
@@ -771,38 +764,37 @@
           <a:p>
             <a:pPr lvl="0"/>
             <a:r>
-              <a:rPr lang="zh-TW" altLang="en-US" smtClean="0"/>
+              <a:rPr lang="zh-TW" altLang="en-US"/>
               <a:t>按一下以編輯母片文字樣式</a:t>
             </a:r>
           </a:p>
           <a:p>
             <a:pPr lvl="1"/>
             <a:r>
-              <a:rPr lang="zh-TW" altLang="en-US" smtClean="0"/>
+              <a:rPr lang="zh-TW" altLang="en-US"/>
               <a:t>第二層</a:t>
             </a:r>
           </a:p>
           <a:p>
             <a:pPr lvl="2"/>
             <a:r>
-              <a:rPr lang="zh-TW" altLang="en-US" smtClean="0"/>
+              <a:rPr lang="zh-TW" altLang="en-US"/>
               <a:t>第三層</a:t>
             </a:r>
           </a:p>
           <a:p>
             <a:pPr lvl="3"/>
             <a:r>
-              <a:rPr lang="zh-TW" altLang="en-US" smtClean="0"/>
+              <a:rPr lang="zh-TW" altLang="en-US"/>
               <a:t>第四層</a:t>
             </a:r>
           </a:p>
           <a:p>
             <a:pPr lvl="4"/>
             <a:r>
-              <a:rPr lang="zh-TW" altLang="en-US" smtClean="0"/>
+              <a:rPr lang="zh-TW" altLang="en-US"/>
               <a:t>第五層</a:t>
             </a:r>
-            <a:endParaRPr lang="zh-TW" altLang="en-US"/>
           </a:p>
         </p:txBody>
       </p:sp>
@@ -824,7 +816,7 @@
             <a:fld id="{8ABE99C2-CC00-45DE-B879-1B21F9649AC3}" type="datetimeFigureOut">
               <a:rPr lang="en-US" smtClean="0"/>
               <a:pPr/>
-              <a:t>2/11/2023</a:t>
+              <a:t>4/12/2025</a:t>
             </a:fld>
             <a:endParaRPr lang="en-US"/>
           </a:p>
@@ -923,10 +915,9 @@
           </a:lstStyle>
           <a:p>
             <a:r>
-              <a:rPr lang="zh-TW" altLang="en-US" smtClean="0"/>
+              <a:rPr lang="zh-TW" altLang="en-US"/>
               <a:t>按一下以編輯母片標題樣式</a:t>
             </a:r>
-            <a:endParaRPr lang="zh-TW" altLang="en-US"/>
           </a:p>
         </p:txBody>
       </p:sp>
@@ -1043,7 +1034,7 @@
           <a:p>
             <a:pPr lvl="0"/>
             <a:r>
-              <a:rPr lang="zh-TW" altLang="en-US" smtClean="0"/>
+              <a:rPr lang="zh-TW" altLang="en-US"/>
               <a:t>按一下以編輯母片文字樣式</a:t>
             </a:r>
           </a:p>
@@ -1067,7 +1058,7 @@
             <a:fld id="{8ABE99C2-CC00-45DE-B879-1B21F9649AC3}" type="datetimeFigureOut">
               <a:rPr lang="en-US" smtClean="0"/>
               <a:pPr/>
-              <a:t>2/11/2023</a:t>
+              <a:t>4/12/2025</a:t>
             </a:fld>
             <a:endParaRPr lang="en-US"/>
           </a:p>
@@ -1157,10 +1148,9 @@
           <a:lstStyle/>
           <a:p>
             <a:r>
-              <a:rPr lang="zh-TW" altLang="en-US" smtClean="0"/>
+              <a:rPr lang="zh-TW" altLang="en-US"/>
               <a:t>按一下以編輯母片標題樣式</a:t>
             </a:r>
-            <a:endParaRPr lang="zh-TW" altLang="en-US"/>
           </a:p>
         </p:txBody>
       </p:sp>
@@ -1214,38 +1204,37 @@
           <a:p>
             <a:pPr lvl="0"/>
             <a:r>
-              <a:rPr lang="zh-TW" altLang="en-US" smtClean="0"/>
+              <a:rPr lang="zh-TW" altLang="en-US"/>
               <a:t>按一下以編輯母片文字樣式</a:t>
             </a:r>
           </a:p>
           <a:p>
             <a:pPr lvl="1"/>
             <a:r>
-              <a:rPr lang="zh-TW" altLang="en-US" smtClean="0"/>
+              <a:rPr lang="zh-TW" altLang="en-US"/>
               <a:t>第二層</a:t>
             </a:r>
           </a:p>
           <a:p>
             <a:pPr lvl="2"/>
             <a:r>
-              <a:rPr lang="zh-TW" altLang="en-US" smtClean="0"/>
+              <a:rPr lang="zh-TW" altLang="en-US"/>
               <a:t>第三層</a:t>
             </a:r>
           </a:p>
           <a:p>
             <a:pPr lvl="3"/>
             <a:r>
-              <a:rPr lang="zh-TW" altLang="en-US" smtClean="0"/>
+              <a:rPr lang="zh-TW" altLang="en-US"/>
               <a:t>第四層</a:t>
             </a:r>
           </a:p>
           <a:p>
             <a:pPr lvl="4"/>
             <a:r>
-              <a:rPr lang="zh-TW" altLang="en-US" smtClean="0"/>
+              <a:rPr lang="zh-TW" altLang="en-US"/>
               <a:t>第五層</a:t>
             </a:r>
-            <a:endParaRPr lang="zh-TW" altLang="en-US"/>
           </a:p>
         </p:txBody>
       </p:sp>
@@ -1299,38 +1288,37 @@
           <a:p>
             <a:pPr lvl="0"/>
             <a:r>
-              <a:rPr lang="zh-TW" altLang="en-US" smtClean="0"/>
+              <a:rPr lang="zh-TW" altLang="en-US"/>
               <a:t>按一下以編輯母片文字樣式</a:t>
             </a:r>
           </a:p>
           <a:p>
             <a:pPr lvl="1"/>
             <a:r>
-              <a:rPr lang="zh-TW" altLang="en-US" smtClean="0"/>
+              <a:rPr lang="zh-TW" altLang="en-US"/>
               <a:t>第二層</a:t>
             </a:r>
           </a:p>
           <a:p>
             <a:pPr lvl="2"/>
             <a:r>
-              <a:rPr lang="zh-TW" altLang="en-US" smtClean="0"/>
+              <a:rPr lang="zh-TW" altLang="en-US"/>
               <a:t>第三層</a:t>
             </a:r>
           </a:p>
           <a:p>
             <a:pPr lvl="3"/>
             <a:r>
-              <a:rPr lang="zh-TW" altLang="en-US" smtClean="0"/>
+              <a:rPr lang="zh-TW" altLang="en-US"/>
               <a:t>第四層</a:t>
             </a:r>
           </a:p>
           <a:p>
             <a:pPr lvl="4"/>
             <a:r>
-              <a:rPr lang="zh-TW" altLang="en-US" smtClean="0"/>
+              <a:rPr lang="zh-TW" altLang="en-US"/>
               <a:t>第五層</a:t>
             </a:r>
-            <a:endParaRPr lang="zh-TW" altLang="en-US"/>
           </a:p>
         </p:txBody>
       </p:sp>
@@ -1352,7 +1340,7 @@
             <a:fld id="{8ABE99C2-CC00-45DE-B879-1B21F9649AC3}" type="datetimeFigureOut">
               <a:rPr lang="en-US" smtClean="0"/>
               <a:pPr/>
-              <a:t>2/11/2023</a:t>
+              <a:t>4/12/2025</a:t>
             </a:fld>
             <a:endParaRPr lang="en-US"/>
           </a:p>
@@ -1446,10 +1434,9 @@
           </a:lstStyle>
           <a:p>
             <a:r>
-              <a:rPr lang="zh-TW" altLang="en-US" smtClean="0"/>
+              <a:rPr lang="zh-TW" altLang="en-US"/>
               <a:t>按一下以編輯母片標題樣式</a:t>
             </a:r>
-            <a:endParaRPr lang="zh-TW" altLang="en-US"/>
           </a:p>
         </p:txBody>
       </p:sp>
@@ -1512,7 +1499,7 @@
           <a:p>
             <a:pPr lvl="0"/>
             <a:r>
-              <a:rPr lang="zh-TW" altLang="en-US" smtClean="0"/>
+              <a:rPr lang="zh-TW" altLang="en-US"/>
               <a:t>按一下以編輯母片文字樣式</a:t>
             </a:r>
           </a:p>
@@ -1568,38 +1555,37 @@
           <a:p>
             <a:pPr lvl="0"/>
             <a:r>
-              <a:rPr lang="zh-TW" altLang="en-US" smtClean="0"/>
+              <a:rPr lang="zh-TW" altLang="en-US"/>
               <a:t>按一下以編輯母片文字樣式</a:t>
             </a:r>
           </a:p>
           <a:p>
             <a:pPr lvl="1"/>
             <a:r>
-              <a:rPr lang="zh-TW" altLang="en-US" smtClean="0"/>
+              <a:rPr lang="zh-TW" altLang="en-US"/>
               <a:t>第二層</a:t>
             </a:r>
           </a:p>
           <a:p>
             <a:pPr lvl="2"/>
             <a:r>
-              <a:rPr lang="zh-TW" altLang="en-US" smtClean="0"/>
+              <a:rPr lang="zh-TW" altLang="en-US"/>
               <a:t>第三層</a:t>
             </a:r>
           </a:p>
           <a:p>
             <a:pPr lvl="3"/>
             <a:r>
-              <a:rPr lang="zh-TW" altLang="en-US" smtClean="0"/>
+              <a:rPr lang="zh-TW" altLang="en-US"/>
               <a:t>第四層</a:t>
             </a:r>
           </a:p>
           <a:p>
             <a:pPr lvl="4"/>
             <a:r>
-              <a:rPr lang="zh-TW" altLang="en-US" smtClean="0"/>
+              <a:rPr lang="zh-TW" altLang="en-US"/>
               <a:t>第五層</a:t>
             </a:r>
-            <a:endParaRPr lang="zh-TW" altLang="en-US"/>
           </a:p>
         </p:txBody>
       </p:sp>
@@ -1662,7 +1648,7 @@
           <a:p>
             <a:pPr lvl="0"/>
             <a:r>
-              <a:rPr lang="zh-TW" altLang="en-US" smtClean="0"/>
+              <a:rPr lang="zh-TW" altLang="en-US"/>
               <a:t>按一下以編輯母片文字樣式</a:t>
             </a:r>
           </a:p>
@@ -1718,38 +1704,37 @@
           <a:p>
             <a:pPr lvl="0"/>
             <a:r>
-              <a:rPr lang="zh-TW" altLang="en-US" smtClean="0"/>
+              <a:rPr lang="zh-TW" altLang="en-US"/>
               <a:t>按一下以編輯母片文字樣式</a:t>
             </a:r>
           </a:p>
           <a:p>
             <a:pPr lvl="1"/>
             <a:r>
-              <a:rPr lang="zh-TW" altLang="en-US" smtClean="0"/>
+              <a:rPr lang="zh-TW" altLang="en-US"/>
               <a:t>第二層</a:t>
             </a:r>
           </a:p>
           <a:p>
             <a:pPr lvl="2"/>
             <a:r>
-              <a:rPr lang="zh-TW" altLang="en-US" smtClean="0"/>
+              <a:rPr lang="zh-TW" altLang="en-US"/>
               <a:t>第三層</a:t>
             </a:r>
           </a:p>
           <a:p>
             <a:pPr lvl="3"/>
             <a:r>
-              <a:rPr lang="zh-TW" altLang="en-US" smtClean="0"/>
+              <a:rPr lang="zh-TW" altLang="en-US"/>
               <a:t>第四層</a:t>
             </a:r>
           </a:p>
           <a:p>
             <a:pPr lvl="4"/>
             <a:r>
-              <a:rPr lang="zh-TW" altLang="en-US" smtClean="0"/>
+              <a:rPr lang="zh-TW" altLang="en-US"/>
               <a:t>第五層</a:t>
             </a:r>
-            <a:endParaRPr lang="zh-TW" altLang="en-US"/>
           </a:p>
         </p:txBody>
       </p:sp>
@@ -1771,7 +1756,7 @@
             <a:fld id="{8ABE99C2-CC00-45DE-B879-1B21F9649AC3}" type="datetimeFigureOut">
               <a:rPr lang="en-US" smtClean="0"/>
               <a:pPr/>
-              <a:t>2/11/2023</a:t>
+              <a:t>4/12/2025</a:t>
             </a:fld>
             <a:endParaRPr lang="en-US"/>
           </a:p>
@@ -1861,10 +1846,9 @@
           <a:lstStyle/>
           <a:p>
             <a:r>
-              <a:rPr lang="zh-TW" altLang="en-US" smtClean="0"/>
+              <a:rPr lang="zh-TW" altLang="en-US"/>
               <a:t>按一下以編輯母片標題樣式</a:t>
             </a:r>
-            <a:endParaRPr lang="zh-TW" altLang="en-US"/>
           </a:p>
         </p:txBody>
       </p:sp>
@@ -1886,7 +1870,7 @@
             <a:fld id="{8ABE99C2-CC00-45DE-B879-1B21F9649AC3}" type="datetimeFigureOut">
               <a:rPr lang="en-US" smtClean="0"/>
               <a:pPr/>
-              <a:t>2/11/2023</a:t>
+              <a:t>4/12/2025</a:t>
             </a:fld>
             <a:endParaRPr lang="en-US"/>
           </a:p>
@@ -1978,7 +1962,7 @@
             <a:fld id="{8ABE99C2-CC00-45DE-B879-1B21F9649AC3}" type="datetimeFigureOut">
               <a:rPr lang="en-US" smtClean="0"/>
               <a:pPr/>
-              <a:t>2/11/2023</a:t>
+              <a:t>4/12/2025</a:t>
             </a:fld>
             <a:endParaRPr lang="en-US"/>
           </a:p>
@@ -2077,10 +2061,9 @@
           </a:lstStyle>
           <a:p>
             <a:r>
-              <a:rPr lang="zh-TW" altLang="en-US" smtClean="0"/>
+              <a:rPr lang="zh-TW" altLang="en-US"/>
               <a:t>按一下以編輯母片標題樣式</a:t>
             </a:r>
-            <a:endParaRPr lang="zh-TW" altLang="en-US"/>
           </a:p>
         </p:txBody>
       </p:sp>
@@ -2134,38 +2117,37 @@
           <a:p>
             <a:pPr lvl="0"/>
             <a:r>
-              <a:rPr lang="zh-TW" altLang="en-US" smtClean="0"/>
+              <a:rPr lang="zh-TW" altLang="en-US"/>
               <a:t>按一下以編輯母片文字樣式</a:t>
             </a:r>
           </a:p>
           <a:p>
             <a:pPr lvl="1"/>
             <a:r>
-              <a:rPr lang="zh-TW" altLang="en-US" smtClean="0"/>
+              <a:rPr lang="zh-TW" altLang="en-US"/>
               <a:t>第二層</a:t>
             </a:r>
           </a:p>
           <a:p>
             <a:pPr lvl="2"/>
             <a:r>
-              <a:rPr lang="zh-TW" altLang="en-US" smtClean="0"/>
+              <a:rPr lang="zh-TW" altLang="en-US"/>
               <a:t>第三層</a:t>
             </a:r>
           </a:p>
           <a:p>
             <a:pPr lvl="3"/>
             <a:r>
-              <a:rPr lang="zh-TW" altLang="en-US" smtClean="0"/>
+              <a:rPr lang="zh-TW" altLang="en-US"/>
               <a:t>第四層</a:t>
             </a:r>
           </a:p>
           <a:p>
             <a:pPr lvl="4"/>
             <a:r>
-              <a:rPr lang="zh-TW" altLang="en-US" smtClean="0"/>
+              <a:rPr lang="zh-TW" altLang="en-US"/>
               <a:t>第五層</a:t>
             </a:r>
-            <a:endParaRPr lang="zh-TW" altLang="en-US"/>
           </a:p>
         </p:txBody>
       </p:sp>
@@ -2228,7 +2210,7 @@
           <a:p>
             <a:pPr lvl="0"/>
             <a:r>
-              <a:rPr lang="zh-TW" altLang="en-US" smtClean="0"/>
+              <a:rPr lang="zh-TW" altLang="en-US"/>
               <a:t>按一下以編輯母片文字樣式</a:t>
             </a:r>
           </a:p>
@@ -2252,7 +2234,7 @@
             <a:fld id="{8ABE99C2-CC00-45DE-B879-1B21F9649AC3}" type="datetimeFigureOut">
               <a:rPr lang="en-US" smtClean="0"/>
               <a:pPr/>
-              <a:t>2/11/2023</a:t>
+              <a:t>4/12/2025</a:t>
             </a:fld>
             <a:endParaRPr lang="en-US"/>
           </a:p>
@@ -2351,10 +2333,9 @@
           </a:lstStyle>
           <a:p>
             <a:r>
-              <a:rPr lang="zh-TW" altLang="en-US" smtClean="0"/>
+              <a:rPr lang="zh-TW" altLang="en-US"/>
               <a:t>按一下以編輯母片標題樣式</a:t>
             </a:r>
-            <a:endParaRPr lang="zh-TW" altLang="en-US"/>
           </a:p>
         </p:txBody>
       </p:sp>
@@ -2416,10 +2397,9 @@
           </a:lstStyle>
           <a:p>
             <a:r>
-              <a:rPr lang="zh-TW" altLang="en-US" smtClean="0"/>
+              <a:rPr lang="zh-TW" altLang="en-US"/>
               <a:t>按一下圖示以新增圖片</a:t>
             </a:r>
-            <a:endParaRPr lang="zh-TW" altLang="en-US"/>
           </a:p>
         </p:txBody>
       </p:sp>
@@ -2482,7 +2462,7 @@
           <a:p>
             <a:pPr lvl="0"/>
             <a:r>
-              <a:rPr lang="zh-TW" altLang="en-US" smtClean="0"/>
+              <a:rPr lang="zh-TW" altLang="en-US"/>
               <a:t>按一下以編輯母片文字樣式</a:t>
             </a:r>
           </a:p>
@@ -2506,7 +2486,7 @@
             <a:fld id="{8ABE99C2-CC00-45DE-B879-1B21F9649AC3}" type="datetimeFigureOut">
               <a:rPr lang="en-US" smtClean="0"/>
               <a:pPr/>
-              <a:t>2/11/2023</a:t>
+              <a:t>4/12/2025</a:t>
             </a:fld>
             <a:endParaRPr lang="en-US"/>
           </a:p>
@@ -2616,10 +2596,9 @@
           <a:lstStyle/>
           <a:p>
             <a:r>
-              <a:rPr lang="zh-TW" altLang="en-US" smtClean="0"/>
+              <a:rPr lang="zh-TW" altLang="en-US"/>
               <a:t>按一下以編輯母片標題樣式</a:t>
             </a:r>
-            <a:endParaRPr lang="zh-TW" altLang="en-US"/>
           </a:p>
         </p:txBody>
       </p:sp>
@@ -2650,38 +2629,37 @@
           <a:p>
             <a:pPr lvl="0"/>
             <a:r>
-              <a:rPr lang="zh-TW" altLang="en-US" smtClean="0"/>
+              <a:rPr lang="zh-TW" altLang="en-US"/>
               <a:t>按一下以編輯母片文字樣式</a:t>
             </a:r>
           </a:p>
           <a:p>
             <a:pPr lvl="1"/>
             <a:r>
-              <a:rPr lang="zh-TW" altLang="en-US" smtClean="0"/>
+              <a:rPr lang="zh-TW" altLang="en-US"/>
               <a:t>第二層</a:t>
             </a:r>
           </a:p>
           <a:p>
             <a:pPr lvl="2"/>
             <a:r>
-              <a:rPr lang="zh-TW" altLang="en-US" smtClean="0"/>
+              <a:rPr lang="zh-TW" altLang="en-US"/>
               <a:t>第三層</a:t>
             </a:r>
           </a:p>
           <a:p>
             <a:pPr lvl="3"/>
             <a:r>
-              <a:rPr lang="zh-TW" altLang="en-US" smtClean="0"/>
+              <a:rPr lang="zh-TW" altLang="en-US"/>
               <a:t>第四層</a:t>
             </a:r>
           </a:p>
           <a:p>
             <a:pPr lvl="4"/>
             <a:r>
-              <a:rPr lang="zh-TW" altLang="en-US" smtClean="0"/>
+              <a:rPr lang="zh-TW" altLang="en-US"/>
               <a:t>第五層</a:t>
             </a:r>
-            <a:endParaRPr lang="zh-TW" altLang="en-US"/>
           </a:p>
         </p:txBody>
       </p:sp>
@@ -2721,7 +2699,7 @@
             <a:fld id="{8ABE99C2-CC00-45DE-B879-1B21F9649AC3}" type="datetimeFigureOut">
               <a:rPr lang="en-US" smtClean="0"/>
               <a:pPr/>
-              <a:t>2/11/2023</a:t>
+              <a:t>4/12/2025</a:t>
             </a:fld>
             <a:endParaRPr lang="en-US"/>
           </a:p>
@@ -3224,7 +3202,7 @@
               <a:buNone/>
             </a:pPr>
             <a:r>
-              <a:rPr lang="zh-TW" altLang="en-US" sz="6400" b="1" dirty="0" smtClean="0">
+              <a:rPr lang="zh-TW" altLang="en-US" sz="6400" b="1" dirty="0">
                 <a:solidFill>
                   <a:srgbClr val="000066"/>
                 </a:solidFill>
@@ -3234,34 +3212,24 @@
               <a:t>求</a:t>
             </a:r>
             <a:r>
-              <a:rPr lang="zh-CN" altLang="en-US" sz="6400" b="1" dirty="0" smtClean="0">
+              <a:rPr lang="zh-CN" altLang="en-US" sz="6400" b="1" dirty="0">
                 <a:solidFill>
                   <a:srgbClr val="000066"/>
                 </a:solidFill>
                 <a:latin typeface="微軟正黑體" pitchFamily="34" charset="-120"/>
                 <a:ea typeface="微軟正黑體" pitchFamily="34" charset="-120"/>
               </a:rPr>
-              <a:t>袮</a:t>
-            </a:r>
-            <a:r>
-              <a:rPr lang="zh-TW" altLang="en-US" sz="6400" b="1" dirty="0" smtClean="0">
+              <a:t>祢</a:t>
+            </a:r>
+            <a:r>
+              <a:rPr lang="zh-TW" altLang="en-US" sz="6400" b="1" dirty="0">
                 <a:solidFill>
                   <a:srgbClr val="000066"/>
                 </a:solidFill>
                 <a:latin typeface="微軟正黑體" pitchFamily="34" charset="-120"/>
                 <a:ea typeface="微軟正黑體" pitchFamily="34" charset="-120"/>
               </a:rPr>
-              <a:t>使</a:t>
-            </a:r>
-            <a:r>
-              <a:rPr lang="zh-TW" altLang="en-US" sz="6400" b="1" dirty="0">
-                <a:solidFill>
-                  <a:srgbClr val="000066"/>
-                </a:solidFill>
-                <a:latin typeface="微軟正黑體" pitchFamily="34" charset="-120"/>
-                <a:ea typeface="微軟正黑體" pitchFamily="34" charset="-120"/>
-              </a:rPr>
-              <a:t>我放下心中</a:t>
+              <a:t>使我放下心中</a:t>
             </a:r>
             <a:r>
               <a:rPr lang="en-US" altLang="zh-TW" sz="6400" b="1" dirty="0">
@@ -3317,7 +3285,7 @@
           <a:p>
             <a:pPr algn="ctr"/>
             <a:r>
-              <a:rPr lang="en-US" sz="3600" b="1" dirty="0" smtClean="0">
+              <a:rPr lang="en-US" sz="3600" b="1" dirty="0">
                 <a:solidFill>
                   <a:srgbClr val="000066"/>
                 </a:solidFill>
@@ -3327,7 +3295,7 @@
               <a:t>( </a:t>
             </a:r>
             <a:r>
-              <a:rPr lang="zh-CN" altLang="en-US" sz="3600" b="1" dirty="0" smtClean="0">
+              <a:rPr lang="zh-CN" altLang="en-US" sz="3600" b="1" dirty="0">
                 <a:solidFill>
                   <a:srgbClr val="000066"/>
                 </a:solidFill>
@@ -3337,24 +3305,14 @@
               <a:t>正歌</a:t>
             </a:r>
             <a:r>
-              <a:rPr lang="en-US" sz="3600" b="1" dirty="0" smtClean="0">
+              <a:rPr lang="en-US" sz="3600" b="1" dirty="0">
                 <a:solidFill>
                   <a:srgbClr val="000066"/>
                 </a:solidFill>
                 <a:latin typeface="Microsoft JhengHei" panose="020B0604030504040204" pitchFamily="34" charset="-120"/>
                 <a:ea typeface="Microsoft JhengHei" panose="020B0604030504040204" pitchFamily="34" charset="-120"/>
               </a:rPr>
-              <a:t> </a:t>
-            </a:r>
-            <a:r>
-              <a:rPr lang="en-US" sz="3600" b="1" dirty="0" smtClean="0">
-                <a:solidFill>
-                  <a:srgbClr val="000066"/>
-                </a:solidFill>
-                <a:latin typeface="Microsoft JhengHei" panose="020B0604030504040204" pitchFamily="34" charset="-120"/>
-                <a:ea typeface="Microsoft JhengHei" panose="020B0604030504040204" pitchFamily="34" charset="-120"/>
-              </a:rPr>
-              <a:t>)</a:t>
+              <a:t> )</a:t>
             </a:r>
             <a:endParaRPr lang="vi-VN" sz="3600" b="1" dirty="0">
               <a:solidFill>
@@ -3443,7 +3401,7 @@
               <a:buNone/>
             </a:pPr>
             <a:r>
-              <a:rPr lang="zh-TW" altLang="en-US" sz="6400" b="1" dirty="0" smtClean="0">
+              <a:rPr lang="zh-TW" altLang="en-US" sz="6400" b="1" dirty="0">
                 <a:solidFill>
                   <a:srgbClr val="000066"/>
                 </a:solidFill>
@@ -3460,27 +3418,17 @@
                 <a:latin typeface="微軟正黑體" pitchFamily="34" charset="-120"/>
                 <a:ea typeface="微軟正黑體" pitchFamily="34" charset="-120"/>
               </a:rPr>
-              <a:t>袮</a:t>
-            </a:r>
-            <a:r>
-              <a:rPr lang="zh-TW" altLang="en-US" sz="6400" b="1" dirty="0" smtClean="0">
+              <a:t>祢</a:t>
+            </a:r>
+            <a:r>
+              <a:rPr lang="zh-TW" altLang="en-US" sz="6400" b="1" dirty="0">
                 <a:solidFill>
                   <a:srgbClr val="000066"/>
                 </a:solidFill>
                 <a:latin typeface="微軟正黑體" pitchFamily="34" charset="-120"/>
                 <a:ea typeface="微軟正黑體" pitchFamily="34" charset="-120"/>
               </a:rPr>
-              <a:t>使</a:t>
-            </a:r>
-            <a:r>
-              <a:rPr lang="zh-TW" altLang="en-US" sz="6400" b="1" dirty="0">
-                <a:solidFill>
-                  <a:srgbClr val="000066"/>
-                </a:solidFill>
-                <a:latin typeface="微軟正黑體" pitchFamily="34" charset="-120"/>
-                <a:ea typeface="微軟正黑體" pitchFamily="34" charset="-120"/>
-              </a:rPr>
-              <a:t>我打碎心中  心中偶像</a:t>
+              <a:t>使我打碎心中  心中偶像</a:t>
             </a:r>
             <a:endParaRPr lang="en-US" sz="6400" b="1" dirty="0">
               <a:solidFill>
@@ -3516,7 +3464,7 @@
           <a:p>
             <a:pPr algn="ctr"/>
             <a:r>
-              <a:rPr lang="en-US" sz="3600" b="1" dirty="0" smtClean="0">
+              <a:rPr lang="en-US" sz="3600" b="1" dirty="0">
                 <a:solidFill>
                   <a:srgbClr val="000066"/>
                 </a:solidFill>
@@ -3526,7 +3474,7 @@
               <a:t>( </a:t>
             </a:r>
             <a:r>
-              <a:rPr lang="zh-CN" altLang="en-US" sz="3600" b="1" dirty="0" smtClean="0">
+              <a:rPr lang="zh-CN" altLang="en-US" sz="3600" b="1" dirty="0">
                 <a:solidFill>
                   <a:srgbClr val="000066"/>
                 </a:solidFill>
@@ -3536,24 +3484,14 @@
               <a:t>正歌</a:t>
             </a:r>
             <a:r>
-              <a:rPr lang="en-US" sz="3600" b="1" dirty="0" smtClean="0">
+              <a:rPr lang="en-US" sz="3600" b="1" dirty="0">
                 <a:solidFill>
                   <a:srgbClr val="000066"/>
                 </a:solidFill>
                 <a:latin typeface="Microsoft JhengHei" panose="020B0604030504040204" pitchFamily="34" charset="-120"/>
                 <a:ea typeface="Microsoft JhengHei" panose="020B0604030504040204" pitchFamily="34" charset="-120"/>
               </a:rPr>
-              <a:t> </a:t>
-            </a:r>
-            <a:r>
-              <a:rPr lang="en-US" sz="3600" b="1" dirty="0" smtClean="0">
-                <a:solidFill>
-                  <a:srgbClr val="000066"/>
-                </a:solidFill>
-                <a:latin typeface="Microsoft JhengHei" panose="020B0604030504040204" pitchFamily="34" charset="-120"/>
-                <a:ea typeface="Microsoft JhengHei" panose="020B0604030504040204" pitchFamily="34" charset="-120"/>
-              </a:rPr>
-              <a:t>)</a:t>
+              <a:t> )</a:t>
             </a:r>
             <a:endParaRPr lang="vi-VN" sz="3600" b="1" dirty="0">
               <a:solidFill>
@@ -3685,7 +3623,7 @@
           <a:p>
             <a:pPr algn="ctr"/>
             <a:r>
-              <a:rPr lang="en-US" sz="3600" b="1" dirty="0" smtClean="0">
+              <a:rPr lang="en-US" sz="3600" b="1" dirty="0">
                 <a:solidFill>
                   <a:srgbClr val="000066"/>
                 </a:solidFill>
@@ -3695,7 +3633,7 @@
               <a:t>( </a:t>
             </a:r>
             <a:r>
-              <a:rPr lang="zh-CN" altLang="en-US" sz="3600" b="1" dirty="0" smtClean="0">
+              <a:rPr lang="zh-CN" altLang="en-US" sz="3600" b="1" dirty="0">
                 <a:solidFill>
                   <a:srgbClr val="000066"/>
                 </a:solidFill>
@@ -3705,24 +3643,14 @@
               <a:t>前副歌</a:t>
             </a:r>
             <a:r>
-              <a:rPr lang="en-US" sz="3600" b="1" dirty="0" smtClean="0">
+              <a:rPr lang="en-US" sz="3600" b="1" dirty="0">
                 <a:solidFill>
                   <a:srgbClr val="000066"/>
                 </a:solidFill>
                 <a:latin typeface="Microsoft JhengHei" panose="020B0604030504040204" pitchFamily="34" charset="-120"/>
                 <a:ea typeface="Microsoft JhengHei" panose="020B0604030504040204" pitchFamily="34" charset="-120"/>
               </a:rPr>
-              <a:t> </a:t>
-            </a:r>
-            <a:r>
-              <a:rPr lang="en-US" sz="3600" b="1" dirty="0" smtClean="0">
-                <a:solidFill>
-                  <a:srgbClr val="000066"/>
-                </a:solidFill>
-                <a:latin typeface="Microsoft JhengHei" panose="020B0604030504040204" pitchFamily="34" charset="-120"/>
-                <a:ea typeface="Microsoft JhengHei" panose="020B0604030504040204" pitchFamily="34" charset="-120"/>
-              </a:rPr>
-              <a:t>)</a:t>
+              <a:t> )</a:t>
             </a:r>
             <a:endParaRPr lang="vi-VN" sz="3600" b="1" dirty="0">
               <a:solidFill>
@@ -3847,7 +3775,7 @@
           <a:p>
             <a:pPr algn="ctr"/>
             <a:r>
-              <a:rPr lang="en-US" sz="3600" b="1" dirty="0" smtClean="0">
+              <a:rPr lang="en-US" sz="3600" b="1" dirty="0">
                 <a:solidFill>
                   <a:srgbClr val="000066"/>
                 </a:solidFill>
@@ -3857,7 +3785,7 @@
               <a:t>( </a:t>
             </a:r>
             <a:r>
-              <a:rPr lang="zh-CN" altLang="en-US" sz="3600" b="1" dirty="0" smtClean="0">
+              <a:rPr lang="zh-CN" altLang="en-US" sz="3600" b="1" dirty="0">
                 <a:solidFill>
                   <a:srgbClr val="000066"/>
                 </a:solidFill>
@@ -3867,24 +3795,14 @@
               <a:t>前副歌</a:t>
             </a:r>
             <a:r>
-              <a:rPr lang="en-US" sz="3600" b="1" dirty="0" smtClean="0">
+              <a:rPr lang="en-US" sz="3600" b="1" dirty="0">
                 <a:solidFill>
                   <a:srgbClr val="000066"/>
                 </a:solidFill>
                 <a:latin typeface="Microsoft JhengHei" panose="020B0604030504040204" pitchFamily="34" charset="-120"/>
                 <a:ea typeface="Microsoft JhengHei" panose="020B0604030504040204" pitchFamily="34" charset="-120"/>
               </a:rPr>
-              <a:t> </a:t>
-            </a:r>
-            <a:r>
-              <a:rPr lang="en-US" sz="3600" b="1" dirty="0" smtClean="0">
-                <a:solidFill>
-                  <a:srgbClr val="000066"/>
-                </a:solidFill>
-                <a:latin typeface="Microsoft JhengHei" panose="020B0604030504040204" pitchFamily="34" charset="-120"/>
-                <a:ea typeface="Microsoft JhengHei" panose="020B0604030504040204" pitchFamily="34" charset="-120"/>
-              </a:rPr>
-              <a:t>)</a:t>
+              <a:t> )</a:t>
             </a:r>
             <a:endParaRPr lang="vi-VN" sz="3600" b="1" dirty="0">
               <a:solidFill>
@@ -4020,7 +3938,7 @@
           <a:p>
             <a:pPr algn="ctr"/>
             <a:r>
-              <a:rPr lang="en-US" sz="3600" b="1" dirty="0" smtClean="0">
+              <a:rPr lang="en-US" sz="3600" b="1" dirty="0">
                 <a:solidFill>
                   <a:srgbClr val="000066"/>
                 </a:solidFill>
@@ -4030,7 +3948,7 @@
               <a:t>( </a:t>
             </a:r>
             <a:r>
-              <a:rPr lang="zh-CN" altLang="en-US" sz="3600" b="1" dirty="0" smtClean="0">
+              <a:rPr lang="zh-CN" altLang="en-US" sz="3600" b="1" dirty="0">
                 <a:solidFill>
                   <a:srgbClr val="000066"/>
                 </a:solidFill>
@@ -4040,24 +3958,14 @@
               <a:t>副歌</a:t>
             </a:r>
             <a:r>
-              <a:rPr lang="en-US" sz="3600" b="1" dirty="0" smtClean="0">
+              <a:rPr lang="en-US" sz="3600" b="1" dirty="0">
                 <a:solidFill>
                   <a:srgbClr val="000066"/>
                 </a:solidFill>
                 <a:latin typeface="Microsoft JhengHei" panose="020B0604030504040204" pitchFamily="34" charset="-120"/>
                 <a:ea typeface="Microsoft JhengHei" panose="020B0604030504040204" pitchFamily="34" charset="-120"/>
               </a:rPr>
-              <a:t> </a:t>
-            </a:r>
-            <a:r>
-              <a:rPr lang="en-US" sz="3600" b="1" dirty="0" smtClean="0">
-                <a:solidFill>
-                  <a:srgbClr val="000066"/>
-                </a:solidFill>
-                <a:latin typeface="Microsoft JhengHei" panose="020B0604030504040204" pitchFamily="34" charset="-120"/>
-                <a:ea typeface="Microsoft JhengHei" panose="020B0604030504040204" pitchFamily="34" charset="-120"/>
-              </a:rPr>
-              <a:t>)</a:t>
+              <a:t> )</a:t>
             </a:r>
             <a:endParaRPr lang="vi-VN" sz="3600" b="1" dirty="0">
               <a:solidFill>
@@ -4209,7 +4117,7 @@
           <a:p>
             <a:pPr algn="ctr"/>
             <a:r>
-              <a:rPr lang="en-US" sz="3600" b="1" dirty="0" smtClean="0">
+              <a:rPr lang="en-US" sz="3600" b="1" dirty="0">
                 <a:solidFill>
                   <a:srgbClr val="000066"/>
                 </a:solidFill>
@@ -4219,7 +4127,7 @@
               <a:t>( </a:t>
             </a:r>
             <a:r>
-              <a:rPr lang="zh-CN" altLang="en-US" sz="3600" b="1" dirty="0" smtClean="0">
+              <a:rPr lang="zh-CN" altLang="en-US" sz="3600" b="1" dirty="0">
                 <a:solidFill>
                   <a:srgbClr val="000066"/>
                 </a:solidFill>
@@ -4229,24 +4137,14 @@
               <a:t>副歌</a:t>
             </a:r>
             <a:r>
-              <a:rPr lang="en-US" sz="3600" b="1" dirty="0" smtClean="0">
+              <a:rPr lang="en-US" sz="3600" b="1" dirty="0">
                 <a:solidFill>
                   <a:srgbClr val="000066"/>
                 </a:solidFill>
                 <a:latin typeface="Microsoft JhengHei" panose="020B0604030504040204" pitchFamily="34" charset="-120"/>
                 <a:ea typeface="Microsoft JhengHei" panose="020B0604030504040204" pitchFamily="34" charset="-120"/>
               </a:rPr>
-              <a:t> </a:t>
-            </a:r>
-            <a:r>
-              <a:rPr lang="en-US" sz="3600" b="1" dirty="0" smtClean="0">
-                <a:solidFill>
-                  <a:srgbClr val="000066"/>
-                </a:solidFill>
-                <a:latin typeface="Microsoft JhengHei" panose="020B0604030504040204" pitchFamily="34" charset="-120"/>
-                <a:ea typeface="Microsoft JhengHei" panose="020B0604030504040204" pitchFamily="34" charset="-120"/>
-              </a:rPr>
-              <a:t>)</a:t>
+              <a:t> )</a:t>
             </a:r>
             <a:endParaRPr lang="vi-VN" sz="3600" b="1" dirty="0">
               <a:solidFill>
@@ -4320,59 +4218,29 @@
                 <a:latin typeface="微軟正黑體" pitchFamily="34" charset="-120"/>
                 <a:ea typeface="微軟正黑體" pitchFamily="34" charset="-120"/>
               </a:rPr>
-              <a:t>為這世界黑暗的角</a:t>
-            </a:r>
-            <a:r>
-              <a:rPr lang="zh-TW" altLang="en-US" sz="6600" b="1" dirty="0" smtClean="0">
+              <a:t>為這世界黑暗的角落</a:t>
+            </a:r>
+            <a:r>
+              <a:rPr lang="en-US" altLang="zh-TW" sz="6600" b="1" dirty="0">
                 <a:solidFill>
                   <a:srgbClr val="000066"/>
                 </a:solidFill>
                 <a:latin typeface="微軟正黑體" pitchFamily="34" charset="-120"/>
                 <a:ea typeface="微軟正黑體" pitchFamily="34" charset="-120"/>
               </a:rPr>
-              <a:t>落</a:t>
-            </a:r>
-            <a:r>
-              <a:rPr lang="en-US" altLang="zh-TW" sz="6600" b="1" dirty="0" smtClean="0">
+              <a:t>  </a:t>
+            </a:r>
+            <a:r>
+              <a:rPr lang="zh-TW" altLang="en-US" sz="6600" b="1" dirty="0">
                 <a:solidFill>
                   <a:srgbClr val="000066"/>
                 </a:solidFill>
                 <a:latin typeface="微軟正黑體" pitchFamily="34" charset="-120"/>
                 <a:ea typeface="微軟正黑體" pitchFamily="34" charset="-120"/>
               </a:rPr>
-              <a:t>  </a:t>
-            </a:r>
-            <a:r>
-              <a:rPr lang="zh-TW" altLang="en-US" sz="6600" b="1" dirty="0" smtClean="0">
-                <a:solidFill>
-                  <a:srgbClr val="000066"/>
-                </a:solidFill>
-                <a:latin typeface="微軟正黑體" pitchFamily="34" charset="-120"/>
-                <a:ea typeface="微軟正黑體" pitchFamily="34" charset="-120"/>
-              </a:rPr>
-              <a:t>我</a:t>
-            </a:r>
-            <a:r>
-              <a:rPr lang="zh-TW" altLang="en-US" sz="6600" b="1" dirty="0">
-                <a:solidFill>
-                  <a:srgbClr val="000066"/>
-                </a:solidFill>
-                <a:latin typeface="微軟正黑體" pitchFamily="34" charset="-120"/>
-                <a:ea typeface="微軟正黑體" pitchFamily="34" charset="-120"/>
-              </a:rPr>
-              <a:t>在這</a:t>
-            </a:r>
-            <a:r>
-              <a:rPr lang="zh-TW" altLang="en-US" sz="6600" b="1" dirty="0" smtClean="0">
-                <a:solidFill>
-                  <a:srgbClr val="000066"/>
-                </a:solidFill>
-                <a:latin typeface="微軟正黑體" pitchFamily="34" charset="-120"/>
-                <a:ea typeface="微軟正黑體" pitchFamily="34" charset="-120"/>
-              </a:rPr>
-              <a:t>裡</a:t>
-            </a:r>
-            <a:endParaRPr lang="en-US" altLang="zh-TW" sz="6600" b="1" dirty="0" smtClean="0">
+              <a:t>我在這裡</a:t>
+            </a:r>
+            <a:endParaRPr lang="en-US" altLang="zh-TW" sz="6600" b="1" dirty="0">
               <a:solidFill>
                 <a:srgbClr val="000066"/>
               </a:solidFill>
@@ -4428,7 +4296,7 @@
           <a:p>
             <a:pPr algn="ctr"/>
             <a:r>
-              <a:rPr lang="en-US" sz="3600" b="1" dirty="0" smtClean="0">
+              <a:rPr lang="en-US" sz="3600" b="1" dirty="0">
                 <a:solidFill>
                   <a:srgbClr val="000066"/>
                 </a:solidFill>
@@ -4438,7 +4306,7 @@
               <a:t>( </a:t>
             </a:r>
             <a:r>
-              <a:rPr lang="zh-CN" altLang="en-US" sz="3600" b="1" dirty="0" smtClean="0">
+              <a:rPr lang="zh-CN" altLang="en-US" sz="3600" b="1" dirty="0">
                 <a:solidFill>
                   <a:srgbClr val="000066"/>
                 </a:solidFill>
@@ -4448,24 +4316,14 @@
               <a:t>橋</a:t>
             </a:r>
             <a:r>
-              <a:rPr lang="en-US" sz="3600" b="1" dirty="0" smtClean="0">
+              <a:rPr lang="en-US" sz="3600" b="1" dirty="0">
                 <a:solidFill>
                   <a:srgbClr val="000066"/>
                 </a:solidFill>
                 <a:latin typeface="Microsoft JhengHei" panose="020B0604030504040204" pitchFamily="34" charset="-120"/>
                 <a:ea typeface="Microsoft JhengHei" panose="020B0604030504040204" pitchFamily="34" charset="-120"/>
               </a:rPr>
-              <a:t> </a:t>
-            </a:r>
-            <a:r>
-              <a:rPr lang="en-US" sz="3600" b="1" dirty="0" smtClean="0">
-                <a:solidFill>
-                  <a:srgbClr val="000066"/>
-                </a:solidFill>
-                <a:latin typeface="Microsoft JhengHei" panose="020B0604030504040204" pitchFamily="34" charset="-120"/>
-                <a:ea typeface="Microsoft JhengHei" panose="020B0604030504040204" pitchFamily="34" charset="-120"/>
-              </a:rPr>
-              <a:t>)</a:t>
+              <a:t> )</a:t>
             </a:r>
             <a:endParaRPr lang="vi-VN" sz="3600" b="1" dirty="0">
               <a:solidFill>
@@ -4539,20 +4397,10 @@
                 <a:latin typeface="微軟正黑體" pitchFamily="34" charset="-120"/>
                 <a:ea typeface="微軟正黑體" pitchFamily="34" charset="-120"/>
               </a:rPr>
-              <a:t>我在這</a:t>
-            </a:r>
-            <a:r>
-              <a:rPr lang="zh-TW" altLang="en-US" sz="6600" b="1" dirty="0" smtClean="0">
-                <a:solidFill>
-                  <a:srgbClr val="000066"/>
-                </a:solidFill>
-                <a:latin typeface="微軟正黑體" pitchFamily="34" charset="-120"/>
-                <a:ea typeface="微軟正黑體" pitchFamily="34" charset="-120"/>
-              </a:rPr>
-              <a:t>裡  </a:t>
-            </a:r>
-            <a:r>
-              <a:rPr lang="en-US" sz="7200" b="1" dirty="0" smtClean="0">
+              <a:t>我在這裡  </a:t>
+            </a:r>
+            <a:r>
+              <a:rPr lang="en-US" sz="7200" b="1" dirty="0">
                 <a:solidFill>
                   <a:srgbClr val="000066"/>
                 </a:solidFill>
@@ -4579,17 +4427,7 @@
                 <a:latin typeface="微軟正黑體" pitchFamily="34" charset="-120"/>
                 <a:ea typeface="微軟正黑體" pitchFamily="34" charset="-120"/>
               </a:rPr>
-              <a:t>我在這</a:t>
-            </a:r>
-            <a:r>
-              <a:rPr lang="zh-TW" altLang="en-US" sz="6600" b="1" dirty="0" smtClean="0">
-                <a:solidFill>
-                  <a:srgbClr val="000066"/>
-                </a:solidFill>
-                <a:latin typeface="微軟正黑體" pitchFamily="34" charset="-120"/>
-                <a:ea typeface="微軟正黑體" pitchFamily="34" charset="-120"/>
-              </a:rPr>
-              <a:t>裡  </a:t>
+              <a:t>我在這裡  </a:t>
             </a:r>
             <a:r>
               <a:rPr lang="en-US" sz="7200" b="1" dirty="0">
@@ -4627,7 +4465,7 @@
           <a:p>
             <a:pPr algn="ctr"/>
             <a:r>
-              <a:rPr lang="en-US" sz="3600" b="1" dirty="0" smtClean="0">
+              <a:rPr lang="en-US" sz="3600" b="1" dirty="0">
                 <a:solidFill>
                   <a:srgbClr val="000066"/>
                 </a:solidFill>
@@ -4637,7 +4475,7 @@
               <a:t>( </a:t>
             </a:r>
             <a:r>
-              <a:rPr lang="zh-CN" altLang="en-US" sz="3600" b="1" dirty="0" smtClean="0">
+              <a:rPr lang="zh-CN" altLang="en-US" sz="3600" b="1" dirty="0">
                 <a:solidFill>
                   <a:srgbClr val="000066"/>
                 </a:solidFill>
@@ -4647,24 +4485,14 @@
               <a:t>橋</a:t>
             </a:r>
             <a:r>
-              <a:rPr lang="en-US" sz="3600" b="1" dirty="0" smtClean="0">
+              <a:rPr lang="en-US" sz="3600" b="1" dirty="0">
                 <a:solidFill>
                   <a:srgbClr val="000066"/>
                 </a:solidFill>
                 <a:latin typeface="Microsoft JhengHei" panose="020B0604030504040204" pitchFamily="34" charset="-120"/>
                 <a:ea typeface="Microsoft JhengHei" panose="020B0604030504040204" pitchFamily="34" charset="-120"/>
               </a:rPr>
-              <a:t> </a:t>
-            </a:r>
-            <a:r>
-              <a:rPr lang="en-US" sz="3600" b="1" dirty="0" smtClean="0">
-                <a:solidFill>
-                  <a:srgbClr val="000066"/>
-                </a:solidFill>
-                <a:latin typeface="Microsoft JhengHei" panose="020B0604030504040204" pitchFamily="34" charset="-120"/>
-                <a:ea typeface="Microsoft JhengHei" panose="020B0604030504040204" pitchFamily="34" charset="-120"/>
-              </a:rPr>
-              <a:t>)</a:t>
+              <a:t> )</a:t>
             </a:r>
             <a:endParaRPr lang="vi-VN" sz="3600" b="1" dirty="0">
               <a:solidFill>

</xml_diff>